<commit_message>
Make violet and fluo lime the main Beyna colours
The dark neutral is now Deep Violet (#1B1046) instead of grey, the
wordmark is violet on light backgrounds and the eyelid crease is fluo
lime. Updated the palette files, guideline colour pages (EN + FR) and
README, and regenerated the whole kit.

Co-Authored-By: Claude Opus 5.5 <noreply@anthropic.com>
Claude-Session: https://claude.ai/code/session_01VSyU3K2edW3v2Qfo5sYkJT
</commit_message>
<xml_diff>
--- a/brand/beyna-agency/presentation/Beyna-Presentation-16x9-EDITABLE.pptx
+++ b/brand/beyna-agency/presentation/Beyna-Presentation-16x9-EDITABLE.pptx
@@ -4184,7 +4184,7 @@
             <a:r>
               <a:rPr b="1" sz="6300" spc="-189">
                 <a:solidFill>
-                  <a:srgbClr val="24242B"/>
+                  <a:srgbClr val="1B1046"/>
                 </a:solidFill>
                 <a:latin typeface="Syne"/>
               </a:rPr>
@@ -4258,7 +4258,7 @@
             <a:r>
               <a:rPr b="1" sz="3600" spc="-54">
                 <a:solidFill>
-                  <a:srgbClr val="24242B"/>
+                  <a:srgbClr val="1B1046"/>
                 </a:solidFill>
                 <a:latin typeface="Syne"/>
               </a:rPr>
@@ -4332,7 +4332,7 @@
             <a:r>
               <a:rPr b="1" sz="3600" spc="-54">
                 <a:solidFill>
-                  <a:srgbClr val="24242B"/>
+                  <a:srgbClr val="1B1046"/>
                 </a:solidFill>
                 <a:latin typeface="Syne"/>
               </a:rPr>
@@ -4406,7 +4406,7 @@
             <a:r>
               <a:rPr b="1" sz="3600" spc="-54">
                 <a:solidFill>
-                  <a:srgbClr val="24242B"/>
+                  <a:srgbClr val="1B1046"/>
                 </a:solidFill>
                 <a:latin typeface="Syne"/>
               </a:rPr>
@@ -4480,7 +4480,7 @@
             <a:r>
               <a:rPr b="1" sz="3600" spc="-54">
                 <a:solidFill>
-                  <a:srgbClr val="24242B"/>
+                  <a:srgbClr val="1B1046"/>
                 </a:solidFill>
                 <a:latin typeface="Syne"/>
               </a:rPr>
@@ -4554,7 +4554,7 @@
             <a:r>
               <a:rPr b="1" sz="3600" spc="-54">
                 <a:solidFill>
-                  <a:srgbClr val="24242B"/>
+                  <a:srgbClr val="1B1046"/>
                 </a:solidFill>
                 <a:latin typeface="Syne"/>
               </a:rPr>
@@ -4798,7 +4798,7 @@
             <a:r>
               <a:rPr b="1" sz="6000" spc="-179">
                 <a:solidFill>
-                  <a:srgbClr val="24242B"/>
+                  <a:srgbClr val="1B1046"/>
                 </a:solidFill>
                 <a:latin typeface="Syne"/>
               </a:rPr>
@@ -5096,7 +5096,7 @@
             <a:r>
               <a:rPr b="1" sz="6000" spc="-179">
                 <a:solidFill>
-                  <a:srgbClr val="24242B"/>
+                  <a:srgbClr val="1B1046"/>
                 </a:solidFill>
                 <a:latin typeface="Syne"/>
               </a:rPr>
@@ -5133,7 +5133,7 @@
             <a:r>
               <a:rPr b="1" sz="3300" spc="-99">
                 <a:solidFill>
-                  <a:srgbClr val="24242B"/>
+                  <a:srgbClr val="1B1046"/>
                 </a:solidFill>
                 <a:latin typeface="Syne"/>
               </a:rPr>
@@ -5207,7 +5207,7 @@
             <a:r>
               <a:rPr b="1" sz="3300" spc="-99">
                 <a:solidFill>
-                  <a:srgbClr val="24242B"/>
+                  <a:srgbClr val="1B1046"/>
                 </a:solidFill>
                 <a:latin typeface="Syne"/>
               </a:rPr>
@@ -5281,7 +5281,7 @@
             <a:r>
               <a:rPr b="1" sz="3300" spc="-99">
                 <a:solidFill>
-                  <a:srgbClr val="24242B"/>
+                  <a:srgbClr val="1B1046"/>
                 </a:solidFill>
                 <a:latin typeface="Syne"/>
               </a:rPr>

</xml_diff>